<commit_message>
Topic 2 IEP exit tickets: show numbered worked steps after each answer
The three questions sit side by side; each answer is followed by one click per
step. The exit ticket answer keys list the same steps.

Co-Authored-By: Claude Opus 5.5 (1M context) <noreply@anthropic.com>
</commit_message>
<xml_diff>
--- a/IEP/t2-lesson1-exit-ticket-IEP-ANSWER-KEY.pptx
+++ b/IEP/t2-lesson1-exit-ticket-IEP-ANSWER-KEY.pptx
@@ -1553,7 +1553,7 @@
         <p:spPr>
           <a:xfrm>
             <a:off x="685800" y="3579876"/>
-            <a:ext cx="10820095" cy="534924"/>
+            <a:ext cx="10820095" cy="774954"/>
           </a:xfrm>
           <a:prstGeom prst="rect">
             <a:avLst/>
@@ -1592,7 +1592,7 @@
                 <a:latin typeface="Segoe UI"/>
                 <a:cs typeface="Segoe UI"/>
               </a:rPr>
-              <a:t xml:space="preserve"> 1. + 6 is outside, so the graph moves up 6. 2. 5 · f(x) = 5x, so the slope is 5. 3. Same slope 4; the point (0, −2) is the y-intercept.</a:t>
+              <a:t xml:space="preserve"> 1. The + 6 is outside f(x), so the graph moves up or down. Plus means up: up 6. 2. Replace f(x) with x: g(x) = 5x. The number with x is 5, so the slope is 5. 3. Parallel means the same slope: m = 4. Put x = 0, y = −2 into y = mx + b: −2 = 4(0) + b, so b = −2. Write it: y = 4x − 2.</a:t>
             </a:r>
             <a:endParaRPr lang="en-US" sz="1575" dirty="0"/>
           </a:p>

</xml_diff>